<commit_message>
Week 6: fill the AEL slot with a peer review of the wikis and a build half-hour
The week 6 page, card s5 and its note were published in 46c0ae7 with a placeholder for
the AEL lecturer. The slot is now a peer review: teams pair up, compare each other's LLM
wiki, agree on their next improvement — from what they saw, from the conversation, or from
an idea they tested on the other team — and then have half an hour to build it. The page
ties the change to the decision log, as week 5 already did for adopting the wiki. The
presenter deck, PDF and PPTX are rebuilt from the cards and notes.

Co-Authored-By: Claude Opus 5.5 (1M context) <noreply@anthropic.com>
</commit_message>
<xml_diff>
--- a/project-documentation/slides/week-06-deck.pptx
+++ b/project-documentation/slides/week-06-deck.pptx
@@ -2145,7 +2145,7 @@
           <a:lstStyle/>
           <a:p>
             <a:r>
-              <a:t>AEL slot: the evaluation of the LLM wiki. The AEL lecturer fills this card in, or uses it to take the floor.</a:t>
+              <a:t>AEL slot: a peer review of the LLM wikis, then one improvement built. Pair the teams. Each pair opens both wikis and compares them: what they hold, how they are organised, how well they answer a question. Each team then chooses its next improvement. It can come from what they saw in the other wiki, from the conversation, or from an idea they already had and tested on the other team. Then half an hour to build it. Teams that kept a different knowledge architecture compare that instead. Remind them that the change is a decision and goes in the decision log.</a:t>
             </a:r>
           </a:p>
         </p:txBody>
@@ -11918,7 +11918,7 @@
                   <a:srgbClr val="111827"/>
                 </a:solidFill>
               </a:rPr>
-              <a:t>Evaluation of the LLM wiki</a:t>
+              <a:t>Compare wikis with a peer team, then build your next improvement</a:t>
             </a:r>
           </a:p>
         </p:txBody>
@@ -11932,7 +11932,7 @@
         <p:spPr>
           <a:xfrm>
             <a:off x="731520" y="2103120"/>
-            <a:ext cx="10698480" cy="3931920"/>
+            <a:ext cx="3261360" cy="3931920"/>
           </a:xfrm>
           <a:prstGeom prst="rect">
             <a:avLst/>
@@ -11951,12 +11951,27 @@
               </a:spcAft>
             </a:pPr>
             <a:r>
-              <a:rPr sz="1800" i="1">
-                <a:solidFill>
-                  <a:srgbClr val="6B7280"/>
-                </a:solidFill>
-              </a:rPr>
-              <a:t>Filled in the session.</a:t>
+              <a:rPr sz="1100" b="1">
+                <a:solidFill>
+                  <a:srgbClr val="4B5563"/>
+                </a:solidFill>
+              </a:rPr>
+              <a:t>COMPARE</a:t>
+            </a:r>
+          </a:p>
+          <a:p>
+            <a:pPr>
+              <a:spcAft>
+                <a:spcPts val="800"/>
+              </a:spcAft>
+            </a:pPr>
+            <a:r>
+              <a:rPr sz="1800">
+                <a:solidFill>
+                  <a:srgbClr val="111827"/>
+                </a:solidFill>
+              </a:rPr>
+              <a:t>Open each other's wiki</a:t>
             </a:r>
           </a:p>
         </p:txBody>
@@ -11964,6 +11979,112 @@
       <p:sp>
         <p:nvSpPr>
           <p:cNvPr id="7" name="TextBox 6"/>
+          <p:cNvSpPr txBox="1"/>
+          <p:nvPr/>
+        </p:nvSpPr>
+        <p:spPr>
+          <a:xfrm>
+            <a:off x="4450080" y="2103120"/>
+            <a:ext cx="3261360" cy="3931920"/>
+          </a:xfrm>
+          <a:prstGeom prst="rect">
+            <a:avLst/>
+          </a:prstGeom>
+          <a:noFill/>
+        </p:spPr>
+        <p:txBody>
+          <a:bodyPr wrap="square">
+            <a:spAutoFit/>
+          </a:bodyPr>
+          <a:lstStyle/>
+          <a:p>
+            <a:pPr>
+              <a:spcAft>
+                <a:spcPts val="800"/>
+              </a:spcAft>
+            </a:pPr>
+            <a:r>
+              <a:rPr sz="1100" b="1">
+                <a:solidFill>
+                  <a:srgbClr val="4B5563"/>
+                </a:solidFill>
+              </a:rPr>
+              <a:t>CHOOSE</a:t>
+            </a:r>
+          </a:p>
+          <a:p>
+            <a:pPr>
+              <a:spcAft>
+                <a:spcPts val="800"/>
+              </a:spcAft>
+            </a:pPr>
+            <a:r>
+              <a:rPr sz="1800">
+                <a:solidFill>
+                  <a:srgbClr val="111827"/>
+                </a:solidFill>
+              </a:rPr>
+              <a:t>One next improvement: seen, discussed, or your own idea tested on them</a:t>
+            </a:r>
+          </a:p>
+        </p:txBody>
+      </p:sp>
+      <p:sp>
+        <p:nvSpPr>
+          <p:cNvPr id="8" name="TextBox 7"/>
+          <p:cNvSpPr txBox="1"/>
+          <p:nvPr/>
+        </p:nvSpPr>
+        <p:spPr>
+          <a:xfrm>
+            <a:off x="8168640" y="2103120"/>
+            <a:ext cx="3261360" cy="3931920"/>
+          </a:xfrm>
+          <a:prstGeom prst="rect">
+            <a:avLst/>
+          </a:prstGeom>
+          <a:noFill/>
+        </p:spPr>
+        <p:txBody>
+          <a:bodyPr wrap="square">
+            <a:spAutoFit/>
+          </a:bodyPr>
+          <a:lstStyle/>
+          <a:p>
+            <a:pPr>
+              <a:spcAft>
+                <a:spcPts val="800"/>
+              </a:spcAft>
+            </a:pPr>
+            <a:r>
+              <a:rPr sz="1100" b="1">
+                <a:solidFill>
+                  <a:srgbClr val="4B5563"/>
+                </a:solidFill>
+              </a:rPr>
+              <a:t>BUILD</a:t>
+            </a:r>
+          </a:p>
+          <a:p>
+            <a:pPr>
+              <a:spcAft>
+                <a:spcPts val="800"/>
+              </a:spcAft>
+            </a:pPr>
+            <a:r>
+              <a:rPr sz="1800" b="1">
+                <a:solidFill>
+                  <a:srgbClr val="111827"/>
+                </a:solidFill>
+              </a:rPr>
+              <a:t>30 minutes</a:t>
+            </a:r>
+          </a:p>
+        </p:txBody>
+      </p:sp>
+      <p:sp>
+        <p:nvSpPr>
+          <p:cNvPr id="9" name="TextBox 8"/>
           <p:cNvSpPr txBox="1"/>
           <p:nvPr/>
         </p:nvSpPr>

</xml_diff>

<commit_message>
Week 6: record the session's work time and rule 6, "It is never done"
The week 6 page was written before the session, and its rulebook card left rule 6 as a
placeholder to be written in the room (46c0ae7). The room wrote "It is never done", and
the work time ran to a schedule on the whiteboard: a target, a definition of done,
subtasks, and 20-minute slots of 15 minutes' work and 5 to switch. Students liked seeing
their progress slot by slot, so the page now records the schedule as a method they can
reuse, and the rule beside it. Card s27 and its note carry the rule; the presenter deck,
PDF and PPTX are rebuilt.

Co-Authored-By: Claude Opus 5.5 (1M context) <noreply@anthropic.com>
</commit_message>
<xml_diff>
--- a/project-documentation/slides/week-06-deck.pptx
+++ b/project-documentation/slides/week-06-deck.pptx
@@ -1865,7 +1865,7 @@
           <a:lstStyle/>
           <a:p>
             <a:r>
-              <a:t>The rulebook. Rules 1 to 3 from weeks 1 to 3; rule 4 from week 4, "Technology is not the barrier"; rule 5 from week 5, know your known and unknown knowns and unknowns. Rule 6 is added together in this session.</a:t>
+              <a:t>The rulebook. Rules 1 to 3 from weeks 1 to 3; rule 4 from week 4, "Technology is not the barrier"; rule 5 from week 5, know your known and unknown knowns and unknowns. Rule 6, "It is never done", was written together in this session.</a:t>
             </a:r>
           </a:p>
         </p:txBody>
@@ -10884,12 +10884,28 @@
               </a:spcAft>
             </a:pPr>
             <a:r>
-              <a:rPr sz="1800" i="1">
-                <a:solidFill>
-                  <a:srgbClr val="6B7280"/>
-                </a:solidFill>
-              </a:rPr>
-              <a:t>Added together in the session.</a:t>
+              <a:rPr sz="1800">
+                <a:solidFill>
+                  <a:srgbClr val="111827"/>
+                </a:solidFill>
+              </a:rPr>
+              <a:t>It is </a:t>
+            </a:r>
+            <a:r>
+              <a:rPr sz="1800" b="1">
+                <a:solidFill>
+                  <a:srgbClr val="111827"/>
+                </a:solidFill>
+              </a:rPr>
+              <a:t>never</a:t>
+            </a:r>
+            <a:r>
+              <a:rPr sz="1800">
+                <a:solidFill>
+                  <a:srgbClr val="111827"/>
+                </a:solidFill>
+              </a:rPr>
+              <a:t> done.</a:t>
             </a:r>
           </a:p>
         </p:txBody>

</xml_diff>

<commit_message>
Week 6: rule 5 on the rulebook card is the one the room wrote
Card s27 gave rule 5 as "Know your (un)known (un)knowns" (46c0ae7). The whiteboard of
5 October numbers the session's rule "#5 → Never make someone else's problem yours", with
the four kinds of knowns and unknowns written beneath it as the discussion that went with
it. The week 5 page and card now carry that wording (6962e3d), and two cards naming two
different rule 5s would leave a student unsure which one stands. The note follows; the
presenter deck, PDF and PPTX are rebuilt.

The card is now 42 words, two over the limit. The extra words are the rule's own, so it
stays, and the worklog says why.

Co-Authored-By: Claude Opus 5.5 (1M context) <noreply@anthropic.com>
</commit_message>
<xml_diff>
--- a/project-documentation/slides/week-06-deck.pptx
+++ b/project-documentation/slides/week-06-deck.pptx
@@ -1865,7 +1865,7 @@
           <a:lstStyle/>
           <a:p>
             <a:r>
-              <a:t>The rulebook. Rules 1 to 3 from weeks 1 to 3; rule 4 from week 4, "Technology is not the barrier"; rule 5 from week 5, know your known and unknown knowns and unknowns. Rule 6, "It is never done", was written together in this session.</a:t>
+              <a:t>The rulebook. Rules 1 to 3 from weeks 1 to 3; rule 4 from week 4, "Technology is not the barrier"; rule 5 from week 5, "Never make someone else's problem yours", written on the board above the four kinds of knowns and unknowns. Rule 6, "It is never done", was written together in this session.</a:t>
             </a:r>
           </a:p>
         </p:txBody>
@@ -10820,7 +10820,7 @@
                   <a:srgbClr val="111827"/>
                 </a:solidFill>
               </a:rPr>
-              <a:t>Know your </a:t>
+              <a:t>Never make </a:t>
             </a:r>
             <a:r>
               <a:rPr sz="1800" b="1">
@@ -10828,7 +10828,7 @@
                   <a:srgbClr val="111827"/>
                 </a:solidFill>
               </a:rPr>
-              <a:t>(un)known (un)knowns</a:t>
+              <a:t>someone else’s</a:t>
             </a:r>
             <a:r>
               <a:rPr sz="1800">
@@ -10836,7 +10836,7 @@
                   <a:srgbClr val="111827"/>
                 </a:solidFill>
               </a:rPr>
-              <a:t>.</a:t>
+              <a:t> problem yours.</a:t>
             </a:r>
           </a:p>
         </p:txBody>

</xml_diff>